<commit_message>
ストック更新: Google / Chrome / Gemini
</commit_message>
<xml_diff>
--- a/docs/logos.pptx
+++ b/docs/logos.pptx
@@ -3090,7 +3090,7 @@
       <p:grpSpPr/>
       <p:pic>
         <p:nvPicPr>
-          <p:cNvPr id="2" name="Picture 1" descr="KDDI.png"/>
+          <p:cNvPr id="2" name="Picture 1" descr="Chrome.png"/>
           <p:cNvPicPr>
             <a:picLocks noChangeAspect="1"/>
           </p:cNvPicPr>
@@ -3104,8 +3104,8 @@
         </p:blipFill>
         <p:spPr>
           <a:xfrm>
-            <a:off x="1205698" y="457200"/>
-            <a:ext cx="575582" cy="268605"/>
+            <a:off x="1050952" y="457200"/>
+            <a:ext cx="885075" cy="268605"/>
           </a:xfrm>
           <a:prstGeom prst="rect">
             <a:avLst/>
@@ -3141,14 +3141,14 @@
                   <a:srgbClr val="404040"/>
                 </a:solidFill>
               </a:rPr>
-              <a:t>KDDI</a:t>
+              <a:t>Chrome</a:t>
             </a:r>
           </a:p>
         </p:txBody>
       </p:sp>
       <p:pic>
         <p:nvPicPr>
-          <p:cNvPr id="4" name="Picture 3" descr="NEC.png"/>
+          <p:cNvPr id="4" name="Picture 3" descr="Gemini.png"/>
           <p:cNvPicPr>
             <a:picLocks noChangeAspect="1"/>
           </p:cNvPicPr>
@@ -3162,8 +3162,8 @@
         </p:blipFill>
         <p:spPr>
           <a:xfrm>
-            <a:off x="3339285" y="457200"/>
-            <a:ext cx="910766" cy="268605"/>
+            <a:off x="3452329" y="457200"/>
+            <a:ext cx="684679" cy="268605"/>
           </a:xfrm>
           <a:prstGeom prst="rect">
             <a:avLst/>
@@ -3199,14 +3199,14 @@
                   <a:srgbClr val="404040"/>
                 </a:solidFill>
               </a:rPr>
-              <a:t>NEC</a:t>
+              <a:t>Gemini</a:t>
             </a:r>
           </a:p>
         </p:txBody>
       </p:sp>
       <p:pic>
         <p:nvPicPr>
-          <p:cNvPr id="6" name="Picture 5" descr="NTTデータ.png"/>
+          <p:cNvPr id="6" name="Picture 5" descr="Google.png"/>
           <p:cNvPicPr>
             <a:picLocks noChangeAspect="1"/>
           </p:cNvPicPr>
@@ -3220,8 +3220,8 @@
         </p:blipFill>
         <p:spPr>
           <a:xfrm>
-            <a:off x="5529787" y="457200"/>
-            <a:ext cx="1132120" cy="268605"/>
+            <a:off x="5828475" y="457200"/>
+            <a:ext cx="534745" cy="268605"/>
           </a:xfrm>
           <a:prstGeom prst="rect">
             <a:avLst/>
@@ -3257,14 +3257,14 @@
                   <a:srgbClr val="404040"/>
                 </a:solidFill>
               </a:rPr>
-              <a:t>NTTデータ</a:t>
+              <a:t>Google</a:t>
             </a:r>
           </a:p>
         </p:txBody>
       </p:sp>
       <p:pic>
         <p:nvPicPr>
-          <p:cNvPr id="8" name="Picture 7" descr="SyncMe.png"/>
+          <p:cNvPr id="8" name="Picture 7" descr="KDDI.png"/>
           <p:cNvPicPr>
             <a:picLocks noChangeAspect="1"/>
           </p:cNvPicPr>
@@ -3278,8 +3278,8 @@
         </p:blipFill>
         <p:spPr>
           <a:xfrm>
-            <a:off x="7841650" y="457200"/>
-            <a:ext cx="1110753" cy="268605"/>
+            <a:off x="8109235" y="457200"/>
+            <a:ext cx="575582" cy="268605"/>
           </a:xfrm>
           <a:prstGeom prst="rect">
             <a:avLst/>
@@ -3315,14 +3315,14 @@
                   <a:srgbClr val="404040"/>
                 </a:solidFill>
               </a:rPr>
-              <a:t>SyncMe</a:t>
+              <a:t>KDDI</a:t>
             </a:r>
           </a:p>
         </p:txBody>
       </p:sp>
       <p:pic>
         <p:nvPicPr>
-          <p:cNvPr id="10" name="Picture 9" descr="ahamo.png"/>
+          <p:cNvPr id="10" name="Picture 9" descr="NEC.png"/>
           <p:cNvPicPr>
             <a:picLocks noChangeAspect="1"/>
           </p:cNvPicPr>
@@ -3336,8 +3336,8 @@
         </p:blipFill>
         <p:spPr>
           <a:xfrm>
-            <a:off x="10450951" y="457200"/>
-            <a:ext cx="494508" cy="268605"/>
+            <a:off x="10242822" y="457200"/>
+            <a:ext cx="910766" cy="268605"/>
           </a:xfrm>
           <a:prstGeom prst="rect">
             <a:avLst/>
@@ -3373,14 +3373,14 @@
                   <a:srgbClr val="404040"/>
                 </a:solidFill>
               </a:rPr>
-              <a:t>ahamo</a:t>
+              <a:t>NEC</a:t>
             </a:r>
           </a:p>
         </p:txBody>
       </p:sp>
       <p:pic>
         <p:nvPicPr>
-          <p:cNvPr id="12" name="Picture 11" descr="dポイント.png"/>
+          <p:cNvPr id="12" name="Picture 11" descr="NTTデータ.png"/>
           <p:cNvPicPr>
             <a:picLocks noChangeAspect="1"/>
           </p:cNvPicPr>
@@ -3394,8 +3394,8 @@
         </p:blipFill>
         <p:spPr>
           <a:xfrm>
-            <a:off x="1389177" y="1228725"/>
-            <a:ext cx="208625" cy="268605"/>
+            <a:off x="927429" y="1228725"/>
+            <a:ext cx="1132120" cy="268605"/>
           </a:xfrm>
           <a:prstGeom prst="rect">
             <a:avLst/>
@@ -3431,14 +3431,14 @@
                   <a:srgbClr val="404040"/>
                 </a:solidFill>
               </a:rPr>
-              <a:t>dポイント</a:t>
+              <a:t>NTTデータ</a:t>
             </a:r>
           </a:p>
         </p:txBody>
       </p:sp>
       <p:pic>
         <p:nvPicPr>
-          <p:cNvPr id="14" name="Picture 13" descr="dマガジン.png"/>
+          <p:cNvPr id="14" name="Picture 13" descr="SyncMe.png"/>
           <p:cNvPicPr>
             <a:picLocks noChangeAspect="1"/>
           </p:cNvPicPr>
@@ -3452,8 +3452,8 @@
         </p:blipFill>
         <p:spPr>
           <a:xfrm>
-            <a:off x="3659929" y="1228725"/>
-            <a:ext cx="269479" cy="268605"/>
+            <a:off x="3239292" y="1228725"/>
+            <a:ext cx="1110753" cy="268605"/>
           </a:xfrm>
           <a:prstGeom prst="rect">
             <a:avLst/>
@@ -3489,14 +3489,14 @@
                   <a:srgbClr val="404040"/>
                 </a:solidFill>
               </a:rPr>
-              <a:t>dマガジン</a:t>
+              <a:t>SyncMe</a:t>
             </a:r>
           </a:p>
         </p:txBody>
       </p:sp>
       <p:pic>
         <p:nvPicPr>
-          <p:cNvPr id="16" name="Picture 15" descr="d払い.png"/>
+          <p:cNvPr id="16" name="Picture 15" descr="ahamo.png"/>
           <p:cNvPicPr>
             <a:picLocks noChangeAspect="1"/>
           </p:cNvPicPr>
@@ -3510,8 +3510,8 @@
         </p:blipFill>
         <p:spPr>
           <a:xfrm>
-            <a:off x="5670071" y="1228725"/>
-            <a:ext cx="851552" cy="268605"/>
+            <a:off x="5848593" y="1228725"/>
+            <a:ext cx="494508" cy="268605"/>
           </a:xfrm>
           <a:prstGeom prst="rect">
             <a:avLst/>
@@ -3547,14 +3547,14 @@
                   <a:srgbClr val="404040"/>
                 </a:solidFill>
               </a:rPr>
-              <a:t>d払い</a:t>
+              <a:t>ahamo</a:t>
             </a:r>
           </a:p>
         </p:txBody>
       </p:sp>
       <p:pic>
         <p:nvPicPr>
-          <p:cNvPr id="18" name="Picture 17" descr="アサヒグループホールディングス.png"/>
+          <p:cNvPr id="18" name="Picture 17" descr="dポイント.png"/>
           <p:cNvPicPr>
             <a:picLocks noChangeAspect="1"/>
           </p:cNvPicPr>
@@ -3568,8 +3568,8 @@
         </p:blipFill>
         <p:spPr>
           <a:xfrm>
-            <a:off x="8208066" y="1228725"/>
-            <a:ext cx="377920" cy="268605"/>
+            <a:off x="8292714" y="1228725"/>
+            <a:ext cx="208625" cy="268605"/>
           </a:xfrm>
           <a:prstGeom prst="rect">
             <a:avLst/>
@@ -3605,14 +3605,14 @@
                   <a:srgbClr val="404040"/>
                 </a:solidFill>
               </a:rPr>
-              <a:t>アサヒグループホールディングス</a:t>
+              <a:t>dポイント</a:t>
             </a:r>
           </a:p>
         </p:txBody>
       </p:sp>
       <p:pic>
         <p:nvPicPr>
-          <p:cNvPr id="20" name="Picture 19" descr="オリエンタルランド.png"/>
+          <p:cNvPr id="20" name="Picture 19" descr="dマガジン.png"/>
           <p:cNvPicPr>
             <a:picLocks noChangeAspect="1"/>
           </p:cNvPicPr>
@@ -3626,8 +3626,8 @@
         </p:blipFill>
         <p:spPr>
           <a:xfrm>
-            <a:off x="10441810" y="1228725"/>
-            <a:ext cx="512791" cy="268605"/>
+            <a:off x="10563466" y="1228725"/>
+            <a:ext cx="269479" cy="268605"/>
           </a:xfrm>
           <a:prstGeom prst="rect">
             <a:avLst/>
@@ -3663,14 +3663,14 @@
                   <a:srgbClr val="404040"/>
                 </a:solidFill>
               </a:rPr>
-              <a:t>オリエンタルランド</a:t>
+              <a:t>dマガジン</a:t>
             </a:r>
           </a:p>
         </p:txBody>
       </p:sp>
       <p:pic>
         <p:nvPicPr>
-          <p:cNvPr id="22" name="Picture 21" descr="オリンパス.png"/>
+          <p:cNvPr id="22" name="Picture 21" descr="d払い.png"/>
           <p:cNvPicPr>
             <a:picLocks noChangeAspect="1"/>
           </p:cNvPicPr>
@@ -3684,8 +3684,8 @@
         </p:blipFill>
         <p:spPr>
           <a:xfrm>
-            <a:off x="884515" y="2000250"/>
-            <a:ext cx="1217949" cy="268605"/>
+            <a:off x="1067713" y="2000250"/>
+            <a:ext cx="851552" cy="268605"/>
           </a:xfrm>
           <a:prstGeom prst="rect">
             <a:avLst/>
@@ -3721,14 +3721,14 @@
                   <a:srgbClr val="404040"/>
                 </a:solidFill>
               </a:rPr>
-              <a:t>オリンパス</a:t>
+              <a:t>d払い</a:t>
             </a:r>
           </a:p>
         </p:txBody>
       </p:sp>
       <p:pic>
         <p:nvPicPr>
-          <p:cNvPr id="24" name="Picture 23" descr="キーエンス.png"/>
+          <p:cNvPr id="24" name="Picture 23" descr="アサヒグループホールディングス.png"/>
           <p:cNvPicPr>
             <a:picLocks noChangeAspect="1"/>
           </p:cNvPicPr>
@@ -3742,8 +3742,8 @@
         </p:blipFill>
         <p:spPr>
           <a:xfrm>
-            <a:off x="3169290" y="2000250"/>
-            <a:ext cx="1250756" cy="268605"/>
+            <a:off x="3605708" y="2000250"/>
+            <a:ext cx="377920" cy="268605"/>
           </a:xfrm>
           <a:prstGeom prst="rect">
             <a:avLst/>
@@ -3779,14 +3779,14 @@
                   <a:srgbClr val="404040"/>
                 </a:solidFill>
               </a:rPr>
-              <a:t>キーエンス</a:t>
+              <a:t>アサヒグループホールディングス</a:t>
             </a:r>
           </a:p>
         </p:txBody>
       </p:sp>
       <p:pic>
         <p:nvPicPr>
-          <p:cNvPr id="26" name="Picture 25" descr="コマツ.png"/>
+          <p:cNvPr id="26" name="Picture 25" descr="オリエンタルランド.png"/>
           <p:cNvPicPr>
             <a:picLocks noChangeAspect="1"/>
           </p:cNvPicPr>
@@ -3800,8 +3800,8 @@
         </p:blipFill>
         <p:spPr>
           <a:xfrm>
-            <a:off x="5481893" y="2000250"/>
-            <a:ext cx="1227908" cy="268605"/>
+            <a:off x="5839452" y="2000250"/>
+            <a:ext cx="512791" cy="268605"/>
           </a:xfrm>
           <a:prstGeom prst="rect">
             <a:avLst/>
@@ -3837,14 +3837,14 @@
                   <a:srgbClr val="404040"/>
                 </a:solidFill>
               </a:rPr>
-              <a:t>コマツ</a:t>
+              <a:t>オリエンタルランド</a:t>
             </a:r>
           </a:p>
         </p:txBody>
       </p:sp>
       <p:pic>
         <p:nvPicPr>
-          <p:cNvPr id="28" name="Picture 27" descr="セコム.png"/>
+          <p:cNvPr id="28" name="Picture 27" descr="オリンパス.png"/>
           <p:cNvPicPr>
             <a:picLocks noChangeAspect="1"/>
           </p:cNvPicPr>
@@ -3858,8 +3858,8 @@
         </p:blipFill>
         <p:spPr>
           <a:xfrm>
-            <a:off x="8049298" y="2000250"/>
-            <a:ext cx="695457" cy="268605"/>
+            <a:off x="7788052" y="2000250"/>
+            <a:ext cx="1217949" cy="268605"/>
           </a:xfrm>
           <a:prstGeom prst="rect">
             <a:avLst/>
@@ -3895,14 +3895,14 @@
                   <a:srgbClr val="404040"/>
                 </a:solidFill>
               </a:rPr>
-              <a:t>セコム</a:t>
+              <a:t>オリンパス</a:t>
             </a:r>
           </a:p>
         </p:txBody>
       </p:sp>
       <p:pic>
         <p:nvPicPr>
-          <p:cNvPr id="30" name="Picture 29" descr="セブン&amp;アイ・ホールディングス.png"/>
+          <p:cNvPr id="30" name="Picture 29" descr="キーエンス.png"/>
           <p:cNvPicPr>
             <a:picLocks noChangeAspect="1"/>
           </p:cNvPicPr>
@@ -3916,8 +3916,8 @@
         </p:blipFill>
         <p:spPr>
           <a:xfrm>
-            <a:off x="10549641" y="2000250"/>
-            <a:ext cx="297129" cy="268605"/>
+            <a:off x="10072827" y="2000250"/>
+            <a:ext cx="1250756" cy="268605"/>
           </a:xfrm>
           <a:prstGeom prst="rect">
             <a:avLst/>
@@ -3953,14 +3953,14 @@
                   <a:srgbClr val="404040"/>
                 </a:solidFill>
               </a:rPr>
-              <a:t>セブン&amp;アイ・ホールディングス</a:t>
+              <a:t>キーエンス</a:t>
             </a:r>
           </a:p>
         </p:txBody>
       </p:sp>
       <p:pic>
         <p:nvPicPr>
-          <p:cNvPr id="32" name="Picture 31" descr="ソニーグループ.png"/>
+          <p:cNvPr id="32" name="Picture 31" descr="コマツ.png"/>
           <p:cNvPicPr>
             <a:picLocks noChangeAspect="1"/>
           </p:cNvPicPr>
@@ -3974,8 +3974,8 @@
         </p:blipFill>
         <p:spPr>
           <a:xfrm>
-            <a:off x="851548" y="2771775"/>
-            <a:ext cx="1283882" cy="268605"/>
+            <a:off x="879535" y="2771775"/>
+            <a:ext cx="1227908" cy="268605"/>
           </a:xfrm>
           <a:prstGeom prst="rect">
             <a:avLst/>
@@ -4011,14 +4011,14 @@
                   <a:srgbClr val="404040"/>
                 </a:solidFill>
               </a:rPr>
-              <a:t>ソニーグループ</a:t>
+              <a:t>コマツ</a:t>
             </a:r>
           </a:p>
         </p:txBody>
       </p:sp>
       <p:pic>
         <p:nvPicPr>
-          <p:cNvPr id="34" name="Picture 33" descr="ダイキン工業.png"/>
+          <p:cNvPr id="34" name="Picture 33" descr="セコム.png"/>
           <p:cNvPicPr>
             <a:picLocks noChangeAspect="1"/>
           </p:cNvPicPr>
@@ -4032,8 +4032,8 @@
         </p:blipFill>
         <p:spPr>
           <a:xfrm>
-            <a:off x="3237058" y="2771775"/>
-            <a:ext cx="1115220" cy="268605"/>
+            <a:off x="3446940" y="2771775"/>
+            <a:ext cx="695457" cy="268605"/>
           </a:xfrm>
           <a:prstGeom prst="rect">
             <a:avLst/>
@@ -4069,14 +4069,14 @@
                   <a:srgbClr val="404040"/>
                 </a:solidFill>
               </a:rPr>
-              <a:t>ダイキン工業</a:t>
+              <a:t>セコム</a:t>
             </a:r>
           </a:p>
         </p:txBody>
       </p:sp>
       <p:pic>
         <p:nvPicPr>
-          <p:cNvPr id="36" name="Picture 35" descr="トヨタ自動車.png"/>
+          <p:cNvPr id="36" name="Picture 35" descr="セブン&amp;アイ・ホールディングス.png"/>
           <p:cNvPicPr>
             <a:picLocks noChangeAspect="1"/>
           </p:cNvPicPr>
@@ -4090,8 +4090,8 @@
         </p:blipFill>
         <p:spPr>
           <a:xfrm>
-            <a:off x="5902517" y="2771775"/>
-            <a:ext cx="386661" cy="268605"/>
+            <a:off x="5947283" y="2771775"/>
+            <a:ext cx="297129" cy="268605"/>
           </a:xfrm>
           <a:prstGeom prst="rect">
             <a:avLst/>
@@ -4127,14 +4127,14 @@
                   <a:srgbClr val="404040"/>
                 </a:solidFill>
               </a:rPr>
-              <a:t>トヨタ自動車</a:t>
+              <a:t>セブン&amp;アイ・ホールディングス</a:t>
             </a:r>
           </a:p>
         </p:txBody>
       </p:sp>
       <p:pic>
         <p:nvPicPr>
-          <p:cNvPr id="38" name="Picture 37" descr="ドコモの銀行.png"/>
+          <p:cNvPr id="38" name="Picture 37" descr="ソニーグループ.png"/>
           <p:cNvPicPr>
             <a:picLocks noChangeAspect="1"/>
           </p:cNvPicPr>
@@ -4148,8 +4148,8 @@
         </p:blipFill>
         <p:spPr>
           <a:xfrm>
-            <a:off x="7957186" y="2771775"/>
-            <a:ext cx="879681" cy="268605"/>
+            <a:off x="7755085" y="2771775"/>
+            <a:ext cx="1283882" cy="268605"/>
           </a:xfrm>
           <a:prstGeom prst="rect">
             <a:avLst/>
@@ -4185,14 +4185,14 @@
                   <a:srgbClr val="404040"/>
                 </a:solidFill>
               </a:rPr>
-              <a:t>ドコモの銀行</a:t>
+              <a:t>ソニーグループ</a:t>
             </a:r>
           </a:p>
         </p:txBody>
       </p:sp>
       <p:pic>
         <p:nvPicPr>
-          <p:cNvPr id="40" name="Picture 39" descr="ドコモ光.png"/>
+          <p:cNvPr id="40" name="Picture 39" descr="ダイキン工業.png"/>
           <p:cNvPicPr>
             <a:picLocks noChangeAspect="1"/>
           </p:cNvPicPr>
@@ -4206,8 +4206,8 @@
         </p:blipFill>
         <p:spPr>
           <a:xfrm>
-            <a:off x="10270504" y="2771775"/>
-            <a:ext cx="855403" cy="268605"/>
+            <a:off x="10140595" y="2771775"/>
+            <a:ext cx="1115220" cy="268605"/>
           </a:xfrm>
           <a:prstGeom prst="rect">
             <a:avLst/>
@@ -4243,14 +4243,14 @@
                   <a:srgbClr val="404040"/>
                 </a:solidFill>
               </a:rPr>
-              <a:t>ドコモ光</a:t>
+              <a:t>ダイキン工業</a:t>
             </a:r>
           </a:p>
         </p:txBody>
       </p:sp>
       <p:pic>
         <p:nvPicPr>
-          <p:cNvPr id="42" name="Picture 41" descr="パナソニック.png"/>
+          <p:cNvPr id="42" name="Picture 41" descr="トヨタ自動車.png"/>
           <p:cNvPicPr>
             <a:picLocks noChangeAspect="1"/>
           </p:cNvPicPr>
@@ -4264,8 +4264,8 @@
         </p:blipFill>
         <p:spPr>
           <a:xfrm>
-            <a:off x="754826" y="3543300"/>
-            <a:ext cx="1477327" cy="268605"/>
+            <a:off x="1300159" y="3543300"/>
+            <a:ext cx="386661" cy="268605"/>
           </a:xfrm>
           <a:prstGeom prst="rect">
             <a:avLst/>
@@ -4301,14 +4301,14 @@
                   <a:srgbClr val="404040"/>
                 </a:solidFill>
               </a:rPr>
-              <a:t>パナソニック</a:t>
+              <a:t>トヨタ自動車</a:t>
             </a:r>
           </a:p>
         </p:txBody>
       </p:sp>
       <p:pic>
         <p:nvPicPr>
-          <p:cNvPr id="44" name="Picture 43" descr="ファーストリテイリング.png"/>
+          <p:cNvPr id="44" name="Picture 43" descr="ドコモの銀行.png"/>
           <p:cNvPicPr>
             <a:picLocks noChangeAspect="1"/>
           </p:cNvPicPr>
@@ -4322,8 +4322,8 @@
         </p:blipFill>
         <p:spPr>
           <a:xfrm>
-            <a:off x="3527929" y="3543300"/>
-            <a:ext cx="533479" cy="268605"/>
+            <a:off x="3354828" y="3543300"/>
+            <a:ext cx="879681" cy="268605"/>
           </a:xfrm>
           <a:prstGeom prst="rect">
             <a:avLst/>
@@ -4359,14 +4359,14 @@
                   <a:srgbClr val="404040"/>
                 </a:solidFill>
               </a:rPr>
-              <a:t>ファーストリテイリング</a:t>
+              <a:t>ドコモの銀行</a:t>
             </a:r>
           </a:p>
         </p:txBody>
       </p:sp>
       <p:pic>
         <p:nvPicPr>
-          <p:cNvPr id="46" name="Picture 45" descr="ホンダ.png"/>
+          <p:cNvPr id="46" name="Picture 45" descr="ドコモ光.png"/>
           <p:cNvPicPr>
             <a:picLocks noChangeAspect="1"/>
           </p:cNvPicPr>
@@ -4380,8 +4380,8 @@
         </p:blipFill>
         <p:spPr>
           <a:xfrm>
-            <a:off x="5257615" y="3543300"/>
-            <a:ext cx="1676465" cy="268605"/>
+            <a:off x="5668146" y="3543300"/>
+            <a:ext cx="855403" cy="268605"/>
           </a:xfrm>
           <a:prstGeom prst="rect">
             <a:avLst/>
@@ -4417,14 +4417,14 @@
                   <a:srgbClr val="404040"/>
                 </a:solidFill>
               </a:rPr>
-              <a:t>ホンダ</a:t>
+              <a:t>ドコモ光</a:t>
             </a:r>
           </a:p>
         </p:txBody>
       </p:sp>
       <p:pic>
         <p:nvPicPr>
-          <p:cNvPr id="48" name="Picture 47" descr="リクルートホールディングス.png"/>
+          <p:cNvPr id="48" name="Picture 47" descr="パナソニック.png"/>
           <p:cNvPicPr>
             <a:picLocks noChangeAspect="1"/>
           </p:cNvPicPr>
@@ -4438,8 +4438,8 @@
         </p:blipFill>
         <p:spPr>
           <a:xfrm>
-            <a:off x="7935323" y="3543300"/>
-            <a:ext cx="923407" cy="268605"/>
+            <a:off x="7658363" y="3543300"/>
+            <a:ext cx="1477327" cy="268605"/>
           </a:xfrm>
           <a:prstGeom prst="rect">
             <a:avLst/>
@@ -4475,14 +4475,14 @@
                   <a:srgbClr val="404040"/>
                 </a:solidFill>
               </a:rPr>
-              <a:t>リクルートホールディングス</a:t>
+              <a:t>パナソニック</a:t>
             </a:r>
           </a:p>
         </p:txBody>
       </p:sp>
       <p:pic>
         <p:nvPicPr>
-          <p:cNvPr id="50" name="Picture 49" descr="三井住友銀行.png"/>
+          <p:cNvPr id="50" name="Picture 49" descr="ファーストリテイリング.png"/>
           <p:cNvPicPr>
             <a:picLocks noChangeAspect="1"/>
           </p:cNvPicPr>
@@ -4496,8 +4496,8 @@
         </p:blipFill>
         <p:spPr>
           <a:xfrm>
-            <a:off x="10251693" y="3543300"/>
-            <a:ext cx="893024" cy="268605"/>
+            <a:off x="10431466" y="3543300"/>
+            <a:ext cx="533479" cy="268605"/>
           </a:xfrm>
           <a:prstGeom prst="rect">
             <a:avLst/>
@@ -4533,14 +4533,14 @@
                   <a:srgbClr val="404040"/>
                 </a:solidFill>
               </a:rPr>
-              <a:t>三井住友銀行</a:t>
+              <a:t>ファーストリテイリング</a:t>
             </a:r>
           </a:p>
         </p:txBody>
       </p:sp>
       <p:pic>
         <p:nvPicPr>
-          <p:cNvPr id="52" name="Picture 51" descr="三菱電機.png"/>
+          <p:cNvPr id="52" name="Picture 51" descr="ホンダ.png"/>
           <p:cNvPicPr>
             <a:picLocks noChangeAspect="1"/>
           </p:cNvPicPr>
@@ -4554,8 +4554,8 @@
         </p:blipFill>
         <p:spPr>
           <a:xfrm>
-            <a:off x="1080251" y="4314825"/>
-            <a:ext cx="826476" cy="268605"/>
+            <a:off x="655257" y="4314825"/>
+            <a:ext cx="1676465" cy="268605"/>
           </a:xfrm>
           <a:prstGeom prst="rect">
             <a:avLst/>
@@ -4591,14 +4591,14 @@
                   <a:srgbClr val="404040"/>
                 </a:solidFill>
               </a:rPr>
-              <a:t>三菱電機</a:t>
+              <a:t>ホンダ</a:t>
             </a:r>
           </a:p>
         </p:txBody>
       </p:sp>
       <p:pic>
         <p:nvPicPr>
-          <p:cNvPr id="54" name="Picture 53" descr="任天堂.png"/>
+          <p:cNvPr id="54" name="Picture 53" descr="リクルートホールディングス.png"/>
           <p:cNvPicPr>
             <a:picLocks noChangeAspect="1"/>
           </p:cNvPicPr>
@@ -4612,8 +4612,8 @@
         </p:blipFill>
         <p:spPr>
           <a:xfrm>
-            <a:off x="3306988" y="4314825"/>
-            <a:ext cx="975360" cy="268605"/>
+            <a:off x="3332965" y="4314825"/>
+            <a:ext cx="923407" cy="268605"/>
           </a:xfrm>
           <a:prstGeom prst="rect">
             <a:avLst/>
@@ -4649,14 +4649,14 @@
                   <a:srgbClr val="404040"/>
                 </a:solidFill>
               </a:rPr>
-              <a:t>任天堂</a:t>
+              <a:t>リクルートホールディングス</a:t>
             </a:r>
           </a:p>
         </p:txBody>
       </p:sp>
       <p:pic>
         <p:nvPicPr>
-          <p:cNvPr id="56" name="Picture 55" descr="味の素.png"/>
+          <p:cNvPr id="56" name="Picture 55" descr="三井住友銀行.png"/>
           <p:cNvPicPr>
             <a:picLocks noChangeAspect="1"/>
           </p:cNvPicPr>
@@ -4670,8 +4670,8 @@
         </p:blipFill>
         <p:spPr>
           <a:xfrm>
-            <a:off x="5267649" y="4314825"/>
-            <a:ext cx="1656397" cy="268605"/>
+            <a:off x="5649335" y="4314825"/>
+            <a:ext cx="893024" cy="268605"/>
           </a:xfrm>
           <a:prstGeom prst="rect">
             <a:avLst/>
@@ -4707,14 +4707,14 @@
                   <a:srgbClr val="404040"/>
                 </a:solidFill>
               </a:rPr>
-              <a:t>味の素</a:t>
+              <a:t>三井住友銀行</a:t>
             </a:r>
           </a:p>
         </p:txBody>
       </p:sp>
       <p:pic>
         <p:nvPicPr>
-          <p:cNvPr id="58" name="Picture 57" descr="大和ハウス工業.png"/>
+          <p:cNvPr id="58" name="Picture 57" descr="三菱電機.png"/>
           <p:cNvPicPr>
             <a:picLocks noChangeAspect="1"/>
           </p:cNvPicPr>
@@ -4728,8 +4728,8 @@
         </p:blipFill>
         <p:spPr>
           <a:xfrm>
-            <a:off x="8228696" y="4314825"/>
-            <a:ext cx="336660" cy="268605"/>
+            <a:off x="7983788" y="4314825"/>
+            <a:ext cx="826476" cy="268605"/>
           </a:xfrm>
           <a:prstGeom prst="rect">
             <a:avLst/>
@@ -4765,14 +4765,14 @@
                   <a:srgbClr val="404040"/>
                 </a:solidFill>
               </a:rPr>
-              <a:t>大和ハウス工業</a:t>
+              <a:t>三菱電機</a:t>
             </a:r>
           </a:p>
         </p:txBody>
       </p:sp>
       <p:pic>
         <p:nvPicPr>
-          <p:cNvPr id="60" name="Picture 59" descr="富士通.png"/>
+          <p:cNvPr id="60" name="Picture 59" descr="任天堂.png"/>
           <p:cNvPicPr>
             <a:picLocks noChangeAspect="1"/>
           </p:cNvPicPr>
@@ -4786,8 +4786,8 @@
         </p:blipFill>
         <p:spPr>
           <a:xfrm>
-            <a:off x="10433223" y="4314825"/>
-            <a:ext cx="529964" cy="268605"/>
+            <a:off x="10210525" y="4314825"/>
+            <a:ext cx="975360" cy="268605"/>
           </a:xfrm>
           <a:prstGeom prst="rect">
             <a:avLst/>
@@ -4823,14 +4823,14 @@
                   <a:srgbClr val="404040"/>
                 </a:solidFill>
               </a:rPr>
-              <a:t>富士通</a:t>
+              <a:t>任天堂</a:t>
             </a:r>
           </a:p>
         </p:txBody>
       </p:sp>
       <p:pic>
         <p:nvPicPr>
-          <p:cNvPr id="62" name="Picture 61" descr="日本郵政.png"/>
+          <p:cNvPr id="62" name="Picture 61" descr="味の素.png"/>
           <p:cNvPicPr>
             <a:picLocks noChangeAspect="1"/>
           </p:cNvPicPr>
@@ -4844,8 +4844,8 @@
         </p:blipFill>
         <p:spPr>
           <a:xfrm>
-            <a:off x="1367477" y="5086350"/>
-            <a:ext cx="252024" cy="268605"/>
+            <a:off x="665291" y="5086350"/>
+            <a:ext cx="1656397" cy="268605"/>
           </a:xfrm>
           <a:prstGeom prst="rect">
             <a:avLst/>
@@ -4881,14 +4881,14 @@
                   <a:srgbClr val="404040"/>
                 </a:solidFill>
               </a:rPr>
-              <a:t>日本郵政</a:t>
+              <a:t>味の素</a:t>
             </a:r>
           </a:p>
         </p:txBody>
       </p:sp>
       <p:pic>
         <p:nvPicPr>
-          <p:cNvPr id="64" name="Picture 63" descr="日立製作所.png"/>
+          <p:cNvPr id="64" name="Picture 63" descr="大和ハウス工業.png"/>
           <p:cNvPicPr>
             <a:picLocks noChangeAspect="1"/>
           </p:cNvPicPr>
@@ -4902,8 +4902,8 @@
         </p:blipFill>
         <p:spPr>
           <a:xfrm>
-            <a:off x="3091896" y="5086350"/>
-            <a:ext cx="1405545" cy="268605"/>
+            <a:off x="3626338" y="5086350"/>
+            <a:ext cx="336660" cy="268605"/>
           </a:xfrm>
           <a:prstGeom prst="rect">
             <a:avLst/>
@@ -4939,14 +4939,14 @@
                   <a:srgbClr val="404040"/>
                 </a:solidFill>
               </a:rPr>
-              <a:t>日立製作所</a:t>
+              <a:t>大和ハウス工業</a:t>
             </a:r>
           </a:p>
         </p:txBody>
       </p:sp>
       <p:pic>
         <p:nvPicPr>
-          <p:cNvPr id="66" name="Picture 65" descr="東京ガス.png"/>
+          <p:cNvPr id="66" name="Picture 65" descr="富士通.png"/>
           <p:cNvPicPr>
             <a:picLocks noChangeAspect="1"/>
           </p:cNvPicPr>
@@ -4960,8 +4960,8 @@
         </p:blipFill>
         <p:spPr>
           <a:xfrm>
-            <a:off x="5452315" y="5086350"/>
-            <a:ext cx="1287065" cy="268605"/>
+            <a:off x="5830865" y="5086350"/>
+            <a:ext cx="529964" cy="268605"/>
           </a:xfrm>
           <a:prstGeom prst="rect">
             <a:avLst/>
@@ -4997,14 +4997,14 @@
                   <a:srgbClr val="404040"/>
                 </a:solidFill>
               </a:rPr>
-              <a:t>東京ガス</a:t>
+              <a:t>富士通</a:t>
             </a:r>
           </a:p>
         </p:txBody>
       </p:sp>
       <p:pic>
         <p:nvPicPr>
-          <p:cNvPr id="68" name="Picture 67" descr="楽天グループ.png"/>
+          <p:cNvPr id="68" name="Picture 67" descr="日本郵政.png"/>
           <p:cNvPicPr>
             <a:picLocks noChangeAspect="1"/>
           </p:cNvPicPr>
@@ -5018,8 +5018,8 @@
         </p:blipFill>
         <p:spPr>
           <a:xfrm>
-            <a:off x="7988229" y="5086350"/>
-            <a:ext cx="817595" cy="268605"/>
+            <a:off x="8271014" y="5086350"/>
+            <a:ext cx="252024" cy="268605"/>
           </a:xfrm>
           <a:prstGeom prst="rect">
             <a:avLst/>
@@ -5055,14 +5055,14 @@
                   <a:srgbClr val="404040"/>
                 </a:solidFill>
               </a:rPr>
-              <a:t>楽天グループ</a:t>
+              <a:t>日本郵政</a:t>
             </a:r>
           </a:p>
         </p:txBody>
       </p:sp>
       <p:pic>
         <p:nvPicPr>
-          <p:cNvPr id="70" name="Picture 69" descr="花王.png"/>
+          <p:cNvPr id="70" name="Picture 69" descr="日立製作所.png"/>
           <p:cNvPicPr>
             <a:picLocks noChangeAspect="1"/>
           </p:cNvPicPr>
@@ -5076,8 +5076,8 @@
         </p:blipFill>
         <p:spPr>
           <a:xfrm>
-            <a:off x="10461409" y="5086350"/>
-            <a:ext cx="473593" cy="268605"/>
+            <a:off x="9995433" y="5086350"/>
+            <a:ext cx="1405545" cy="268605"/>
           </a:xfrm>
           <a:prstGeom prst="rect">
             <a:avLst/>
@@ -5113,14 +5113,14 @@
                   <a:srgbClr val="404040"/>
                 </a:solidFill>
               </a:rPr>
-              <a:t>花王</a:t>
+              <a:t>日立製作所</a:t>
             </a:r>
           </a:p>
         </p:txBody>
       </p:sp>
       <p:pic>
         <p:nvPicPr>
-          <p:cNvPr id="72" name="Picture 71" descr="資生堂.png"/>
+          <p:cNvPr id="72" name="Picture 71" descr="東京ガス.png"/>
           <p:cNvPicPr>
             <a:picLocks noChangeAspect="1"/>
           </p:cNvPicPr>
@@ -5134,8 +5134,8 @@
         </p:blipFill>
         <p:spPr>
           <a:xfrm>
-            <a:off x="822632" y="5857875"/>
-            <a:ext cx="1341714" cy="268605"/>
+            <a:off x="849957" y="5857875"/>
+            <a:ext cx="1287065" cy="268605"/>
           </a:xfrm>
           <a:prstGeom prst="rect">
             <a:avLst/>
@@ -5171,14 +5171,14 @@
                   <a:srgbClr val="404040"/>
                 </a:solidFill>
               </a:rPr>
-              <a:t>資生堂</a:t>
+              <a:t>東京ガス</a:t>
             </a:r>
           </a:p>
         </p:txBody>
       </p:sp>
       <p:pic>
         <p:nvPicPr>
-          <p:cNvPr id="74" name="Picture 73" descr="野村ホールディングス.png"/>
+          <p:cNvPr id="74" name="Picture 73" descr="楽天グループ.png"/>
           <p:cNvPicPr>
             <a:picLocks noChangeAspect="1"/>
           </p:cNvPicPr>
@@ -5192,8 +5192,8 @@
         </p:blipFill>
         <p:spPr>
           <a:xfrm>
-            <a:off x="3149008" y="5857875"/>
-            <a:ext cx="1291321" cy="268605"/>
+            <a:off x="3385871" y="5857875"/>
+            <a:ext cx="817595" cy="268605"/>
           </a:xfrm>
           <a:prstGeom prst="rect">
             <a:avLst/>
@@ -5209,6 +5209,180 @@
         <p:spPr>
           <a:xfrm>
             <a:off x="2758379" y="6126480"/>
+            <a:ext cx="2072579" cy="274320"/>
+          </a:xfrm>
+          <a:prstGeom prst="rect">
+            <a:avLst/>
+          </a:prstGeom>
+          <a:noFill/>
+        </p:spPr>
+        <p:txBody>
+          <a:bodyPr wrap="square">
+            <a:spAutoFit/>
+          </a:bodyPr>
+          <a:lstStyle/>
+          <a:p>
+            <a:pPr algn="ctr"/>
+            <a:r>
+              <a:rPr sz="1000">
+                <a:solidFill>
+                  <a:srgbClr val="404040"/>
+                </a:solidFill>
+              </a:rPr>
+              <a:t>楽天グループ</a:t>
+            </a:r>
+          </a:p>
+        </p:txBody>
+      </p:sp>
+      <p:pic>
+        <p:nvPicPr>
+          <p:cNvPr id="76" name="Picture 75" descr="花王.png"/>
+          <p:cNvPicPr>
+            <a:picLocks noChangeAspect="1"/>
+          </p:cNvPicPr>
+          <p:nvPr/>
+        </p:nvPicPr>
+        <p:blipFill>
+          <a:blip r:embed="rId39"/>
+          <a:stretch>
+            <a:fillRect/>
+          </a:stretch>
+        </p:blipFill>
+        <p:spPr>
+          <a:xfrm>
+            <a:off x="5859051" y="5857875"/>
+            <a:ext cx="473593" cy="268605"/>
+          </a:xfrm>
+          <a:prstGeom prst="rect">
+            <a:avLst/>
+          </a:prstGeom>
+        </p:spPr>
+      </p:pic>
+      <p:sp>
+        <p:nvSpPr>
+          <p:cNvPr id="77" name="TextBox 76"/>
+          <p:cNvSpPr txBox="1"/>
+          <p:nvPr/>
+        </p:nvSpPr>
+        <p:spPr>
+          <a:xfrm>
+            <a:off x="5059558" y="6126480"/>
+            <a:ext cx="2072579" cy="274320"/>
+          </a:xfrm>
+          <a:prstGeom prst="rect">
+            <a:avLst/>
+          </a:prstGeom>
+          <a:noFill/>
+        </p:spPr>
+        <p:txBody>
+          <a:bodyPr wrap="square">
+            <a:spAutoFit/>
+          </a:bodyPr>
+          <a:lstStyle/>
+          <a:p>
+            <a:pPr algn="ctr"/>
+            <a:r>
+              <a:rPr sz="1000">
+                <a:solidFill>
+                  <a:srgbClr val="404040"/>
+                </a:solidFill>
+              </a:rPr>
+              <a:t>花王</a:t>
+            </a:r>
+          </a:p>
+        </p:txBody>
+      </p:sp>
+      <p:pic>
+        <p:nvPicPr>
+          <p:cNvPr id="78" name="Picture 77" descr="資生堂.png"/>
+          <p:cNvPicPr>
+            <a:picLocks noChangeAspect="1"/>
+          </p:cNvPicPr>
+          <p:nvPr/>
+        </p:nvPicPr>
+        <p:blipFill>
+          <a:blip r:embed="rId40"/>
+          <a:stretch>
+            <a:fillRect/>
+          </a:stretch>
+        </p:blipFill>
+        <p:spPr>
+          <a:xfrm>
+            <a:off x="7726169" y="5857875"/>
+            <a:ext cx="1341714" cy="268605"/>
+          </a:xfrm>
+          <a:prstGeom prst="rect">
+            <a:avLst/>
+          </a:prstGeom>
+        </p:spPr>
+      </p:pic>
+      <p:sp>
+        <p:nvSpPr>
+          <p:cNvPr id="79" name="TextBox 78"/>
+          <p:cNvSpPr txBox="1"/>
+          <p:nvPr/>
+        </p:nvSpPr>
+        <p:spPr>
+          <a:xfrm>
+            <a:off x="7360737" y="6126480"/>
+            <a:ext cx="2072579" cy="274320"/>
+          </a:xfrm>
+          <a:prstGeom prst="rect">
+            <a:avLst/>
+          </a:prstGeom>
+          <a:noFill/>
+        </p:spPr>
+        <p:txBody>
+          <a:bodyPr wrap="square">
+            <a:spAutoFit/>
+          </a:bodyPr>
+          <a:lstStyle/>
+          <a:p>
+            <a:pPr algn="ctr"/>
+            <a:r>
+              <a:rPr sz="1000">
+                <a:solidFill>
+                  <a:srgbClr val="404040"/>
+                </a:solidFill>
+              </a:rPr>
+              <a:t>資生堂</a:t>
+            </a:r>
+          </a:p>
+        </p:txBody>
+      </p:sp>
+      <p:pic>
+        <p:nvPicPr>
+          <p:cNvPr id="80" name="Picture 79" descr="野村ホールディングス.png"/>
+          <p:cNvPicPr>
+            <a:picLocks noChangeAspect="1"/>
+          </p:cNvPicPr>
+          <p:nvPr/>
+        </p:nvPicPr>
+        <p:blipFill>
+          <a:blip r:embed="rId41"/>
+          <a:stretch>
+            <a:fillRect/>
+          </a:stretch>
+        </p:blipFill>
+        <p:spPr>
+          <a:xfrm>
+            <a:off x="10052545" y="5857875"/>
+            <a:ext cx="1291321" cy="268605"/>
+          </a:xfrm>
+          <a:prstGeom prst="rect">
+            <a:avLst/>
+          </a:prstGeom>
+        </p:spPr>
+      </p:pic>
+      <p:sp>
+        <p:nvSpPr>
+          <p:cNvPr id="81" name="TextBox 80"/>
+          <p:cNvSpPr txBox="1"/>
+          <p:nvPr/>
+        </p:nvSpPr>
+        <p:spPr>
+          <a:xfrm>
+            <a:off x="9661916" y="6126480"/>
             <a:ext cx="2072579" cy="274320"/>
           </a:xfrm>
           <a:prstGeom prst="rect">

</xml_diff>